<commit_message>
Restore red.py to original mentee-level code, update PPT accordingly
Co-authored-by: Cursor <cursoragent@cursor.com>
</commit_message>
<xml_diff>
--- a/week 1/presentation.pptx
+++ b/week 1/presentation.pptx
@@ -3179,7 +3179,7 @@
               </a:defRPr>
             </a:pPr>
             <a:r>
-              <a:t>베어곰 멘토  |  2026.07</a:t>
+              <a:t>장승민 멘티  |  베어곰 멘토  |  2026.07</a:t>
             </a:r>
           </a:p>
         </p:txBody>
@@ -4034,7 +4034,7 @@
               </a:defRPr>
             </a:pPr>
             <a:r>
-              <a:t>import cv2, numpy as np</a:t>
+              <a:t>import cv2</a:t>
             </a:r>
           </a:p>
           <a:p>
@@ -4046,6 +4046,39 @@
               </a:defRPr>
             </a:pPr>
             <a:r>
+              <a:t>import numpy as np</a:t>
+            </a:r>
+          </a:p>
+          <a:p>
+            <a:pPr>
+              <a:defRPr sz="1400" b="0">
+                <a:solidFill>
+                  <a:srgbClr val="555555"/>
+                </a:solidFill>
+              </a:defRPr>
+            </a:pPr>
+          </a:p>
+          <a:p>
+            <a:pPr>
+              <a:defRPr sz="1400" b="0">
+                <a:solidFill>
+                  <a:srgbClr val="555555"/>
+                </a:solidFill>
+              </a:defRPr>
+            </a:pPr>
+            <a:r>
+              <a:t># 이미지 로드</a:t>
+            </a:r>
+          </a:p>
+          <a:p>
+            <a:pPr>
+              <a:defRPr sz="1400" b="0">
+                <a:solidFill>
+                  <a:srgbClr val="555555"/>
+                </a:solidFill>
+              </a:defRPr>
+            </a:pPr>
+            <a:r>
               <a:t>image = cv2.imread('sample.jpg')</a:t>
             </a:r>
           </a:p>
@@ -4058,6 +4091,63 @@
               </a:defRPr>
             </a:pPr>
             <a:r>
+              <a:t>if image is None:</a:t>
+            </a:r>
+          </a:p>
+          <a:p>
+            <a:pPr>
+              <a:defRPr sz="1400" b="0">
+                <a:solidFill>
+                  <a:srgbClr val="555555"/>
+                </a:solidFill>
+              </a:defRPr>
+            </a:pPr>
+            <a:r>
+              <a:t>    print('오류 ...')</a:t>
+            </a:r>
+          </a:p>
+          <a:p>
+            <a:pPr>
+              <a:defRPr sz="1400" b="0">
+                <a:solidFill>
+                  <a:srgbClr val="555555"/>
+                </a:solidFill>
+              </a:defRPr>
+            </a:pPr>
+            <a:r>
+              <a:t>    exit()</a:t>
+            </a:r>
+          </a:p>
+          <a:p>
+            <a:pPr>
+              <a:defRPr sz="1400" b="0">
+                <a:solidFill>
+                  <a:srgbClr val="555555"/>
+                </a:solidFill>
+              </a:defRPr>
+            </a:pPr>
+          </a:p>
+          <a:p>
+            <a:pPr>
+              <a:defRPr sz="1400" b="0">
+                <a:solidFill>
+                  <a:srgbClr val="555555"/>
+                </a:solidFill>
+              </a:defRPr>
+            </a:pPr>
+            <a:r>
+              <a:t># BGR → HSV 변환</a:t>
+            </a:r>
+          </a:p>
+          <a:p>
+            <a:pPr>
+              <a:defRPr sz="1400" b="0">
+                <a:solidFill>
+                  <a:srgbClr val="555555"/>
+                </a:solidFill>
+              </a:defRPr>
+            </a:pPr>
+            <a:r>
               <a:t>hsv = cv2.cvtColor(image,</a:t>
             </a:r>
           </a:p>
@@ -4183,6 +4273,15 @@
                 </a:solidFill>
               </a:defRPr>
             </a:pPr>
+          </a:p>
+          <a:p>
+            <a:pPr>
+              <a:defRPr sz="1400" b="0">
+                <a:solidFill>
+                  <a:srgbClr val="555555"/>
+                </a:solidFill>
+              </a:defRPr>
+            </a:pPr>
             <a:r>
               <a:t>result = cv2.bitwise_and(</a:t>
             </a:r>
@@ -4196,7 +4295,7 @@
               </a:defRPr>
             </a:pPr>
             <a:r>
-              <a:t>    image,image, mask=mask)</a:t>
+              <a:t>    image, image, mask=mask)</a:t>
             </a:r>
           </a:p>
           <a:p>
@@ -4207,6 +4306,15 @@
                 </a:solidFill>
               </a:defRPr>
             </a:pPr>
+          </a:p>
+          <a:p>
+            <a:pPr>
+              <a:defRPr sz="1400" b="0">
+                <a:solidFill>
+                  <a:srgbClr val="555555"/>
+                </a:solidFill>
+              </a:defRPr>
+            </a:pPr>
             <a:r>
               <a:t>cv2.imwrite(</a:t>
             </a:r>
@@ -4220,7 +4328,7 @@
               </a:defRPr>
             </a:pPr>
             <a:r>
-              <a:t>    'red_filtered.jpg',</a:t>
+              <a:t>    'red_filtered.jpg', result)</a:t>
             </a:r>
           </a:p>
           <a:p>
@@ -4232,7 +4340,19 @@
               </a:defRPr>
             </a:pPr>
             <a:r>
-              <a:t>    result)</a:t>
+              <a:t>print('결과 저장 완료')</a:t>
+            </a:r>
+          </a:p>
+          <a:p>
+            <a:pPr>
+              <a:defRPr sz="1400" b="0">
+                <a:solidFill>
+                  <a:srgbClr val="555555"/>
+                </a:solidFill>
+              </a:defRPr>
+            </a:pPr>
+            <a:r>
+              <a:t>print('끝')</a:t>
             </a:r>
           </a:p>
         </p:txBody>

</xml_diff>